<commit_message>
paper-figure: append-to-workspace delivery, box sub-labels, safer saves
- figkit: box(sub=...) second line in the note size; figure(origin="center",
  notes=...) for existing decks; picture anchors use the snapped position;
  script tokens split so r^{p-1} sets p italic and -1 upright;
  Deck.save refuses when a ~$ lock shows the deck is open in PowerPoint
- audit: a sentence boundary needs ". " + capital, so "Aux. tail" passes
- SKILL.md: when the user names a workspace deck, append new slides there
  (backup, PowerPoint-closed check, C14N diff of existing slides)
- taste-log: 2026-10-17 feedback (palette, single column, same deck)

Co-Authored-By: Claude Opus 5.5 <noreply@anthropic.com>
</commit_message>
<xml_diff>
--- a/paper-figure/examples/specimen.pptx
+++ b/paper-figure/examples/specimen.pptx
@@ -3378,6 +3378,17 @@
               <a:t>r</a:t>
             </a:r>
             <a:r>
+              <a:rPr b="0" i="1" sz="1600" baseline="30000">
+                <a:solidFill>
+                  <a:srgbClr val="212529"/>
+                </a:solidFill>
+                <a:latin typeface="Inter"/>
+                <a:ea typeface="Inter"/>
+                <a:cs typeface="Inter"/>
+              </a:rPr>
+              <a:t>p</a:t>
+            </a:r>
+            <a:r>
               <a:rPr b="0" i="0" sz="1600" baseline="30000">
                 <a:solidFill>
                   <a:srgbClr val="212529"/>
@@ -3386,7 +3397,7 @@
                 <a:ea typeface="Inter"/>
                 <a:cs typeface="Inter"/>
               </a:rPr>
-              <a:t>p−1</a:t>
+              <a:t>−1</a:t>
             </a:r>
             <a:r>
               <a:rPr b="0" i="0" sz="1600">

</xml_diff>